<commit_message>
Mise à jour des règles
</commit_message>
<xml_diff>
--- a/pictures/Memos/memo-fr.pptx
+++ b/pictures/Memos/memo-fr.pptx
@@ -197,7 +197,7 @@
           <a:p>
             <a:fld id="{849D895D-661B-479D-A688-27E503324CF6}" type="datetimeFigureOut">
               <a:rPr lang="fr-FR" smtClean="0"/>
-              <a:t>05/07/2026</a:t>
+              <a:t>30/09/2026</a:t>
             </a:fld>
             <a:endParaRPr lang="fr-FR"/>
           </a:p>
@@ -679,7 +679,7 @@
           <a:p>
             <a:fld id="{017B969D-5DBB-4D98-A8ED-E39D79CDECF7}" type="datetimeFigureOut">
               <a:rPr lang="fr-FR" smtClean="0"/>
-              <a:t>05/07/2026</a:t>
+              <a:t>30/09/2026</a:t>
             </a:fld>
             <a:endParaRPr lang="fr-FR"/>
           </a:p>
@@ -849,7 +849,7 @@
           <a:p>
             <a:fld id="{017B969D-5DBB-4D98-A8ED-E39D79CDECF7}" type="datetimeFigureOut">
               <a:rPr lang="fr-FR" smtClean="0"/>
-              <a:t>05/07/2026</a:t>
+              <a:t>30/09/2026</a:t>
             </a:fld>
             <a:endParaRPr lang="fr-FR"/>
           </a:p>
@@ -1029,7 +1029,7 @@
           <a:p>
             <a:fld id="{017B969D-5DBB-4D98-A8ED-E39D79CDECF7}" type="datetimeFigureOut">
               <a:rPr lang="fr-FR" smtClean="0"/>
-              <a:t>05/07/2026</a:t>
+              <a:t>30/09/2026</a:t>
             </a:fld>
             <a:endParaRPr lang="fr-FR"/>
           </a:p>
@@ -1199,7 +1199,7 @@
           <a:p>
             <a:fld id="{017B969D-5DBB-4D98-A8ED-E39D79CDECF7}" type="datetimeFigureOut">
               <a:rPr lang="fr-FR" smtClean="0"/>
-              <a:t>05/07/2026</a:t>
+              <a:t>30/09/2026</a:t>
             </a:fld>
             <a:endParaRPr lang="fr-FR"/>
           </a:p>
@@ -1445,7 +1445,7 @@
           <a:p>
             <a:fld id="{017B969D-5DBB-4D98-A8ED-E39D79CDECF7}" type="datetimeFigureOut">
               <a:rPr lang="fr-FR" smtClean="0"/>
-              <a:t>05/07/2026</a:t>
+              <a:t>30/09/2026</a:t>
             </a:fld>
             <a:endParaRPr lang="fr-FR"/>
           </a:p>
@@ -1677,7 +1677,7 @@
           <a:p>
             <a:fld id="{017B969D-5DBB-4D98-A8ED-E39D79CDECF7}" type="datetimeFigureOut">
               <a:rPr lang="fr-FR" smtClean="0"/>
-              <a:t>05/07/2026</a:t>
+              <a:t>30/09/2026</a:t>
             </a:fld>
             <a:endParaRPr lang="fr-FR"/>
           </a:p>
@@ -2044,7 +2044,7 @@
           <a:p>
             <a:fld id="{017B969D-5DBB-4D98-A8ED-E39D79CDECF7}" type="datetimeFigureOut">
               <a:rPr lang="fr-FR" smtClean="0"/>
-              <a:t>05/07/2026</a:t>
+              <a:t>30/09/2026</a:t>
             </a:fld>
             <a:endParaRPr lang="fr-FR"/>
           </a:p>
@@ -2162,7 +2162,7 @@
           <a:p>
             <a:fld id="{017B969D-5DBB-4D98-A8ED-E39D79CDECF7}" type="datetimeFigureOut">
               <a:rPr lang="fr-FR" smtClean="0"/>
-              <a:t>05/07/2026</a:t>
+              <a:t>30/09/2026</a:t>
             </a:fld>
             <a:endParaRPr lang="fr-FR"/>
           </a:p>
@@ -2257,7 +2257,7 @@
           <a:p>
             <a:fld id="{017B969D-5DBB-4D98-A8ED-E39D79CDECF7}" type="datetimeFigureOut">
               <a:rPr lang="fr-FR" smtClean="0"/>
-              <a:t>05/07/2026</a:t>
+              <a:t>30/09/2026</a:t>
             </a:fld>
             <a:endParaRPr lang="fr-FR"/>
           </a:p>
@@ -2534,7 +2534,7 @@
           <a:p>
             <a:fld id="{017B969D-5DBB-4D98-A8ED-E39D79CDECF7}" type="datetimeFigureOut">
               <a:rPr lang="fr-FR" smtClean="0"/>
-              <a:t>05/07/2026</a:t>
+              <a:t>30/09/2026</a:t>
             </a:fld>
             <a:endParaRPr lang="fr-FR"/>
           </a:p>
@@ -2791,7 +2791,7 @@
           <a:p>
             <a:fld id="{017B969D-5DBB-4D98-A8ED-E39D79CDECF7}" type="datetimeFigureOut">
               <a:rPr lang="fr-FR" smtClean="0"/>
-              <a:t>05/07/2026</a:t>
+              <a:t>30/09/2026</a:t>
             </a:fld>
             <a:endParaRPr lang="fr-FR"/>
           </a:p>
@@ -3004,7 +3004,7 @@
           <a:p>
             <a:fld id="{017B969D-5DBB-4D98-A8ED-E39D79CDECF7}" type="datetimeFigureOut">
               <a:rPr lang="fr-FR" smtClean="0"/>
-              <a:t>05/07/2026</a:t>
+              <a:t>30/09/2026</a:t>
             </a:fld>
             <a:endParaRPr lang="fr-FR"/>
           </a:p>
@@ -4850,10 +4850,10 @@
       </p:sp>
       <p:pic>
         <p:nvPicPr>
-          <p:cNvPr id="14" name="Image 13">
+          <p:cNvPr id="25" name="Image 24">
             <a:extLst>
               <a:ext uri="{FF2B5EF4-FFF2-40B4-BE49-F238E27FC236}">
-                <a16:creationId xmlns:a16="http://schemas.microsoft.com/office/drawing/2014/main" id="{1144B545-CC35-190B-52DA-97E13E34059D}"/>
+                <a16:creationId xmlns:a16="http://schemas.microsoft.com/office/drawing/2014/main" id="{ED83B125-A9EB-5974-EAED-6EF7FF6D31B1}"/>
               </a:ext>
             </a:extLst>
           </p:cNvPr>
@@ -4862,36 +4862,20 @@
           </p:cNvPicPr>
           <p:nvPr/>
         </p:nvPicPr>
-        <p:blipFill rotWithShape="1">
-          <a:blip r:embed="rId11">
-            <a:extLst>
-              <a:ext uri="{28A0092B-C50C-407E-A947-70E740481C1C}">
-                <a14:useLocalDpi xmlns:a14="http://schemas.microsoft.com/office/drawing/2010/main" val="0"/>
-              </a:ext>
-            </a:extLst>
-          </a:blip>
-          <a:srcRect l="35780" r="35811" b="24080"/>
+        <p:blipFill>
+          <a:blip r:embed="rId11"/>
           <a:stretch>
             <a:fillRect/>
           </a:stretch>
         </p:blipFill>
-        <p:spPr bwMode="auto">
-          <a:xfrm>
-            <a:off x="2143352" y="8910041"/>
-            <a:ext cx="5046038" cy="1507584"/>
+        <p:spPr>
+          <a:xfrm>
+            <a:off x="2428059" y="8998243"/>
+            <a:ext cx="4692906" cy="1372364"/>
           </a:xfrm>
           <a:prstGeom prst="rect">
             <a:avLst/>
           </a:prstGeom>
-          <a:noFill/>
-          <a:ln>
-            <a:noFill/>
-          </a:ln>
-          <a:extLst>
-            <a:ext uri="{53640926-AAD7-44D8-BBD7-CCE9431645EC}">
-              <a14:shadowObscured xmlns:a14="http://schemas.microsoft.com/office/drawing/2010/main"/>
-            </a:ext>
-          </a:extLst>
         </p:spPr>
       </p:pic>
     </p:spTree>

</xml_diff>

<commit_message>
Mise à jour des règles et polissage
</commit_message>
<xml_diff>
--- a/pictures/Memos/memo-fr.pptx
+++ b/pictures/Memos/memo-fr.pptx
@@ -4850,10 +4850,10 @@
       </p:sp>
       <p:pic>
         <p:nvPicPr>
-          <p:cNvPr id="25" name="Image 24">
+          <p:cNvPr id="2" name="Image 1">
             <a:extLst>
               <a:ext uri="{FF2B5EF4-FFF2-40B4-BE49-F238E27FC236}">
-                <a16:creationId xmlns:a16="http://schemas.microsoft.com/office/drawing/2014/main" id="{ED83B125-A9EB-5974-EAED-6EF7FF6D31B1}"/>
+                <a16:creationId xmlns:a16="http://schemas.microsoft.com/office/drawing/2014/main" id="{63775F4F-AA3F-23FB-B56F-35D5FA77BBAD}"/>
               </a:ext>
             </a:extLst>
           </p:cNvPr>
@@ -4862,20 +4862,36 @@
           </p:cNvPicPr>
           <p:nvPr/>
         </p:nvPicPr>
-        <p:blipFill>
-          <a:blip r:embed="rId11"/>
+        <p:blipFill rotWithShape="1">
+          <a:blip r:embed="rId11">
+            <a:extLst>
+              <a:ext uri="{28A0092B-C50C-407E-A947-70E740481C1C}">
+                <a14:useLocalDpi xmlns:a14="http://schemas.microsoft.com/office/drawing/2010/main" val="0"/>
+              </a:ext>
+            </a:extLst>
+          </a:blip>
+          <a:srcRect l="35373" r="35464" b="24411"/>
           <a:stretch>
             <a:fillRect/>
           </a:stretch>
         </p:blipFill>
-        <p:spPr>
-          <a:xfrm>
-            <a:off x="2428059" y="8998243"/>
-            <a:ext cx="4692906" cy="1372364"/>
+        <p:spPr bwMode="auto">
+          <a:xfrm>
+            <a:off x="2295526" y="9060313"/>
+            <a:ext cx="4166292" cy="1207188"/>
           </a:xfrm>
           <a:prstGeom prst="rect">
             <a:avLst/>
           </a:prstGeom>
+          <a:noFill/>
+          <a:ln>
+            <a:noFill/>
+          </a:ln>
+          <a:extLst>
+            <a:ext uri="{53640926-AAD7-44D8-BBD7-CCE9431645EC}">
+              <a14:shadowObscured xmlns:a14="http://schemas.microsoft.com/office/drawing/2010/main"/>
+            </a:ext>
+          </a:extLst>
         </p:spPr>
       </p:pic>
     </p:spTree>

</xml_diff>